<commit_message>
Correctifs issus des tests Docker : docs, présentation, test E2E automatisé
</commit_message>
<xml_diff>
--- a/presentation/PRESENTATION_SOAP_CLIENTS.pptx
+++ b/presentation/PRESENTATION_SOAP_CLIENTS.pptx
@@ -3864,7 +3864,7 @@
                 <a:ea typeface="Cambria" pitchFamily="34" charset="-122"/>
                 <a:cs typeface="Cambria" pitchFamily="34" charset="-120"/>
               </a:rPr>
-              <a:t>20 / 20</a:t>
+              <a:t>18 / 18</a:t>
             </a:r>
             <a:endParaRPr lang="en-US" sz="2400" dirty="0"/>
           </a:p>
@@ -3903,7 +3903,7 @@
                 <a:ea typeface="Calibri" pitchFamily="34" charset="-122"/>
                 <a:cs typeface="Calibri" pitchFamily="34" charset="-120"/>
               </a:rPr>
-              <a:t>tests SOAP de bout en bout</a:t>
+              <a:t>tests SOAP sur pile Docker réelle</a:t>
             </a:r>
             <a:endParaRPr lang="en-US" sz="1200" dirty="0"/>
           </a:p>
@@ -4152,7 +4152,7 @@
                 <a:ea typeface="Calibri" pitchFamily="34" charset="-122"/>
                 <a:cs typeface="Calibri" pitchFamily="34" charset="-120"/>
               </a:rPr>
-              <a:t>À valider au 1er `docker compose up` : image Laravel, dépôt Mongo réel, template Zabbix.</a:t>
+              <a:t>Validé sur pile Docker réelle : image Laravel, dépôt Mongo, template Zabbix 7.0, scénario MySQL → Mongo → SOAP → MySQL.</a:t>
             </a:r>
             <a:endParaRPr lang="en-US" sz="1100" dirty="0"/>
           </a:p>
@@ -6775,7 +6775,7 @@
       </p:sp>
       <p:sp>
         <p:nvSpPr>
-          <p:cNvPr id="12" name="boite-Laravel 11"/>
+          <p:cNvPr id="12" name="boite-Laravel 12"/>
           <p:cNvSpPr/>
           <p:nvPr/>
         </p:nvSpPr>
@@ -6833,7 +6833,7 @@
                 <a:ea typeface="Cambria" pitchFamily="34" charset="-122"/>
                 <a:cs typeface="Cambria" pitchFamily="34" charset="-120"/>
               </a:rPr>
-              <a:t>Laravel 11</a:t>
+              <a:t>Laravel 12</a:t>
             </a:r>
             <a:endParaRPr lang="en-US" sz="1500" dirty="0"/>
           </a:p>
@@ -11659,7 +11659,7 @@
                 <a:ea typeface="Calibri" pitchFamily="34" charset="-122"/>
                 <a:cs typeface="Calibri" pitchFamily="34" charset="-120"/>
               </a:rPr>
-              <a:t>http://localhost:8080/soap/clients?wsdl   —   testé avec SoapClient PHP et SoapUI</a:t>
+              <a:t>http://localhost:8080/soap/clients?wsdl   —   testé sur la pile Docker (18 cas) · requêtes SoapUI fournies</a:t>
             </a:r>
             <a:endParaRPr lang="en-US" sz="1400" dirty="0"/>
           </a:p>

</xml_diff>

<commit_message>
feat(soap) complete and validate group 5 delivery
Document the SOAP contract, validation rules and reconciliation strategy.
Protect SOAP-owned records from stale imports and concurrent updates.
Correct Airflow discovery, local container settings and secret handling.
Update the vulnerable Symfony Mime dependency without broad upgrades.
Add real Zabbix checks and a controlled outage verification scenario.
Record 33 unit tests, 23 SOAP tests, 27 pipeline checks and 9 Zabbix checks.
Update the group presentation with member names and verified results.
</commit_message>
<xml_diff>
--- a/presentation/PRESENTATION_SOAP_CLIENTS.pptx
+++ b/presentation/PRESENTATION_SOAP_CLIENTS.pptx
@@ -187,7 +187,7 @@
                 </a:solidFill>
                 <a:latin typeface="+mn-lt"/>
               </a:rPr>
-              <a:t>20 cas de test SOAP par domaine</a:t>
+              <a:t>23 cas de test SOAP par domaine</a:t>
             </a:r>
           </a:p>
         </c:rich>
@@ -211,7 +211,7 @@
               <c:strCache>
                 <c:ptCount val="1"/>
                 <c:pt idx="0">
-                  <c:v>Cas de test</c:v>
+                  <c:v>Nombre de cas</c:v>
                 </c:pt>
               </c:strCache>
             </c:strRef>
@@ -248,32 +248,30 @@
             <c:showLeaderLines val="0"/>
           </c:dLbls>
           <c:cat>
-            <c:multiLvlStrRef>
+            <c:strRef>
               <c:f>Sheet1!$A$2:$A$7</c:f>
-              <c:multiLvlStrCache>
+              <c:strCache>
                 <c:ptCount val="6"/>
-                <c:lvl>
-                  <c:pt idx="0">
-                    <c:v>WSDL</c:v>
-                  </c:pt>
-                  <c:pt idx="1">
-                    <c:v>getClientDetails</c:v>
-                  </c:pt>
-                  <c:pt idx="2">
-                    <c:v>searchClients</c:v>
-                  </c:pt>
-                  <c:pt idx="3">
-                    <c:v>updateClient</c:v>
-                  </c:pt>
-                  <c:pt idx="4">
-                    <c:v>Enveloppe</c:v>
-                  </c:pt>
-                  <c:pt idx="5">
-                    <c:v>Panne base</c:v>
-                  </c:pt>
-                </c:lvl>
-              </c:multiLvlStrCache>
-            </c:multiLvlStrRef>
+                <c:pt idx="0">
+                  <c:v>WSDL</c:v>
+                </c:pt>
+                <c:pt idx="1">
+                  <c:v>getClientDetails</c:v>
+                </c:pt>
+                <c:pt idx="2">
+                  <c:v>searchClients</c:v>
+                </c:pt>
+                <c:pt idx="3">
+                  <c:v>updateClient</c:v>
+                </c:pt>
+                <c:pt idx="4">
+                  <c:v>Enveloppe</c:v>
+                </c:pt>
+                <c:pt idx="5">
+                  <c:v>Panne base</c:v>
+                </c:pt>
+              </c:strCache>
+            </c:strRef>
           </c:cat>
           <c:val>
             <c:numRef>
@@ -288,13 +286,13 @@
                   <c:v>3</c:v>
                 </c:pt>
                 <c:pt idx="2">
-                  <c:v>5</c:v>
+                  <c:v>7</c:v>
                 </c:pt>
                 <c:pt idx="3">
                   <c:v>8</c:v>
                 </c:pt>
                 <c:pt idx="4">
-                  <c:v>1</c:v>
+                  <c:v>2</c:v>
                 </c:pt>
                 <c:pt idx="5">
                   <c:v>2</c:v>
@@ -3674,7 +3672,7 @@
                 <a:ea typeface="Calibri" pitchFamily="34" charset="-122"/>
                 <a:cs typeface="Calibri" pitchFamily="34" charset="-120"/>
               </a:rPr>
-              <a:t>Template « SOAP Clients Service » : 12 éléments, 6 déclencheurs, 2 graphiques. Configuration automatisée par zabbix/setup_zabbix.py.</a:t>
+              <a:t>14 éléments, 8 déclencheurs, 2 graphiques. WSDL, appel SOAP et panne MongoDB testés sur Zabbix 7.0.32.</a:t>
             </a:r>
             <a:endParaRPr lang="en-US" sz="1400" dirty="0"/>
           </a:p>
@@ -3864,7 +3862,7 @@
                 <a:ea typeface="Cambria" pitchFamily="34" charset="-122"/>
                 <a:cs typeface="Cambria" pitchFamily="34" charset="-120"/>
               </a:rPr>
-              <a:t>18 / 18</a:t>
+              <a:t>23 / 23</a:t>
             </a:r>
             <a:endParaRPr lang="en-US" sz="2400" dirty="0"/>
           </a:p>
@@ -3969,7 +3967,7 @@
                 <a:ea typeface="Cambria" pitchFamily="34" charset="-122"/>
                 <a:cs typeface="Cambria" pitchFamily="34" charset="-120"/>
               </a:rPr>
-              <a:t>21 / 21</a:t>
+              <a:t>33 / 33</a:t>
             </a:r>
             <a:endParaRPr lang="en-US" sz="2400" dirty="0"/>
           </a:p>
@@ -4008,7 +4006,7 @@
                 <a:ea typeface="Calibri" pitchFamily="34" charset="-122"/>
                 <a:cs typeface="Calibri" pitchFamily="34" charset="-120"/>
               </a:rPr>
-              <a:t>tests ETL et réconciliation</a:t>
+              <a:t>tests Python ETL / réconciliation</a:t>
             </a:r>
             <a:endParaRPr lang="en-US" sz="1200" dirty="0"/>
           </a:p>
@@ -4074,7 +4072,7 @@
                 <a:ea typeface="Cambria" pitchFamily="34" charset="-122"/>
                 <a:cs typeface="Cambria" pitchFamily="34" charset="-120"/>
               </a:rPr>
-              <a:t>2 / 2</a:t>
+              <a:t>27 / 27</a:t>
             </a:r>
             <a:endParaRPr lang="en-US" sz="2400" dirty="0"/>
           </a:p>
@@ -4113,7 +4111,7 @@
                 <a:ea typeface="Calibri" pitchFamily="34" charset="-122"/>
                 <a:cs typeface="Calibri" pitchFamily="34" charset="-120"/>
               </a:rPr>
-              <a:t>DAG importés dans Airflow 2.9.3</a:t>
+              <a:t>contrôles de la chaîne complète</a:t>
             </a:r>
             <a:endParaRPr lang="en-US" sz="1200" dirty="0"/>
           </a:p>
@@ -4152,7 +4150,7 @@
                 <a:ea typeface="Calibri" pitchFamily="34" charset="-122"/>
                 <a:cs typeface="Calibri" pitchFamily="34" charset="-120"/>
               </a:rPr>
-              <a:t>Validé sur pile Docker réelle : image Laravel, dépôt Mongo, template Zabbix 7.0, scénario MySQL → Mongo → SOAP → MySQL.</a:t>
+              <a:t>Zabbix : 9 contrôles, panne MongoDB détectée puis résolue. Couverture Python : 98 %.</a:t>
             </a:r>
             <a:endParaRPr lang="en-US" sz="1100" dirty="0"/>
           </a:p>
@@ -4260,7 +4258,7 @@
                   <a:schemeClr val="tx2"/>
                 </a:solidFill>
               </a:rPr>
-              <a:t>Répartition du travail</a:t>
+              <a:t>Membres du groupe 5 SI</a:t>
             </a:r>
             <a:endParaRPr lang="en-US" sz="3000" dirty="0"/>
           </a:p>
@@ -4375,7 +4373,7 @@
                 <a:ea typeface="Calibri" pitchFamily="34" charset="-122"/>
                 <a:cs typeface="Calibri" pitchFamily="34" charset="-120"/>
               </a:rPr>
-              <a:t>Membre 1</a:t>
+              <a:t>SANKARA</a:t>
             </a:r>
             <a:endParaRPr lang="en-US" sz="1400" dirty="0"/>
           </a:p>
@@ -4414,7 +4412,7 @@
                 <a:ea typeface="Calibri" pitchFamily="34" charset="-122"/>
                 <a:cs typeface="Calibri" pitchFamily="34" charset="-120"/>
               </a:rPr>
-              <a:t>Infrastructure Docker, dépôt Git, README</a:t>
+              <a:t>Michail Alioun Juste</a:t>
             </a:r>
             <a:endParaRPr lang="en-US" sz="1300" dirty="0"/>
           </a:p>
@@ -4529,7 +4527,7 @@
                 <a:ea typeface="Calibri" pitchFamily="34" charset="-122"/>
                 <a:cs typeface="Calibri" pitchFamily="34" charset="-120"/>
               </a:rPr>
-              <a:t>Membre 2</a:t>
+              <a:t>KOANDA</a:t>
             </a:r>
             <a:endParaRPr lang="en-US" sz="1400" dirty="0"/>
           </a:p>
@@ -4568,7 +4566,7 @@
                 <a:ea typeface="Calibri" pitchFamily="34" charset="-122"/>
                 <a:cs typeface="Calibri" pitchFamily="34" charset="-120"/>
               </a:rPr>
-              <a:t>MySQL, jeu de données, DAG 1 (ETL)</a:t>
+              <a:t>GILDAS</a:t>
             </a:r>
             <a:endParaRPr lang="en-US" sz="1300" dirty="0"/>
           </a:p>
@@ -4683,7 +4681,7 @@
                 <a:ea typeface="Calibri" pitchFamily="34" charset="-122"/>
                 <a:cs typeface="Calibri" pitchFamily="34" charset="-120"/>
               </a:rPr>
-              <a:t>Membre 3</a:t>
+              <a:t>BARRY</a:t>
             </a:r>
             <a:endParaRPr lang="en-US" sz="1400" dirty="0"/>
           </a:p>
@@ -4722,7 +4720,7 @@
                 <a:ea typeface="Calibri" pitchFamily="34" charset="-122"/>
                 <a:cs typeface="Calibri" pitchFamily="34" charset="-120"/>
               </a:rPr>
-              <a:t>Service SOAP Laravel, WSDL, validation</a:t>
+              <a:t>EL NOUR</a:t>
             </a:r>
             <a:endParaRPr lang="en-US" sz="1300" dirty="0"/>
           </a:p>
@@ -4837,7 +4835,7 @@
                 <a:ea typeface="Calibri" pitchFamily="34" charset="-122"/>
                 <a:cs typeface="Calibri" pitchFamily="34" charset="-120"/>
               </a:rPr>
-              <a:t>Membre 4</a:t>
+              <a:t>CONGO</a:t>
             </a:r>
             <a:endParaRPr lang="en-US" sz="1400" dirty="0"/>
           </a:p>
@@ -4876,7 +4874,7 @@
                 <a:ea typeface="Calibri" pitchFamily="34" charset="-122"/>
                 <a:cs typeface="Calibri" pitchFamily="34" charset="-120"/>
               </a:rPr>
-              <a:t>MongoDB, DAG 2, réconciliation</a:t>
+              <a:t>Bénéré Nelson Cephas</a:t>
             </a:r>
             <a:endParaRPr lang="en-US" sz="1300" dirty="0"/>
           </a:p>
@@ -4991,7 +4989,7 @@
                 <a:ea typeface="Calibri" pitchFamily="34" charset="-122"/>
                 <a:cs typeface="Calibri" pitchFamily="34" charset="-120"/>
               </a:rPr>
-              <a:t>Membre 5</a:t>
+              <a:t>KONE</a:t>
             </a:r>
             <a:endParaRPr lang="en-US" sz="1400" dirty="0"/>
           </a:p>
@@ -5030,7 +5028,7 @@
                 <a:ea typeface="Calibri" pitchFamily="34" charset="-122"/>
                 <a:cs typeface="Calibri" pitchFamily="34" charset="-120"/>
               </a:rPr>
-              <a:t>Zabbix, tests SoapUI, documentation</a:t>
+              <a:t>Assita</a:t>
             </a:r>
             <a:endParaRPr lang="en-US" sz="1300" dirty="0"/>
           </a:p>
@@ -5069,7 +5067,7 @@
                 <a:ea typeface="Calibri" pitchFamily="34" charset="-122"/>
                 <a:cs typeface="Calibri" pitchFamily="34" charset="-120"/>
               </a:rPr>
-              <a:t>Noms et rôles à ajuster par le groupe.</a:t>
+              <a:t>IBAM · Groupe 5 SI · Exercice 7 · 2026</a:t>
             </a:r>
             <a:endParaRPr lang="en-US" sz="1100" dirty="0"/>
           </a:p>
@@ -5310,7 +5308,7 @@
                 <a:ea typeface="Calibri" pitchFamily="34" charset="-122"/>
                 <a:cs typeface="Calibri" pitchFamily="34" charset="-120"/>
               </a:rPr>
-              <a:t>Limites : fenêtre d'incohérence jusqu'à 1 h · pas d'authentification SOAP · pas de création/suppression de clients</a:t>
+              <a:t>Limites : délai lié aux DAG et aux reprises · accès local sans authentification SOAP · pas de création/suppression</a:t>
             </a:r>
             <a:endParaRPr lang="en-US" sz="1300" dirty="0"/>
           </a:p>
@@ -7339,7 +7337,7 @@
                 <a:ea typeface="Calibri" pitchFamily="34" charset="-122"/>
                 <a:cs typeface="Calibri" pitchFamily="34" charset="-120"/>
               </a:rPr>
-              <a:t>agent HTTP : /health (30 s) · /monitoring/stats (1 min)</a:t>
+              <a:t>Santé, métriques, WSDL et consultation SOAP périodique</a:t>
             </a:r>
             <a:endParaRPr lang="en-US" sz="1200" dirty="0"/>
           </a:p>
@@ -7378,7 +7376,7 @@
                 <a:ea typeface="Calibri" pitchFamily="34" charset="-122"/>
                 <a:cs typeface="Calibri" pitchFamily="34" charset="-120"/>
               </a:rPr>
-              <a:t>11 conteneurs, un seul `docker compose up -d --build`</a:t>
+              <a:t>11 services Compose · secrets générés localement · ports locaux</a:t>
             </a:r>
             <a:endParaRPr lang="en-US" sz="1400" dirty="0"/>
           </a:p>
@@ -9882,7 +9880,7 @@
                           <a:ea typeface="Calibri" pitchFamily="34" charset="-122"/>
                           <a:cs typeface="Calibri" pitchFamily="34" charset="-120"/>
                         </a:rPr>
-                        <a:t>mise à jour + version + 1</a:t>
+                        <a:t>mise à jour si la fiche reste gérée par MySQL</a:t>
                       </a:r>
                       <a:endParaRPr lang="en-US" sz="1300" dirty="0">
                         <a:latin typeface="Calibri" charset="0"/>
@@ -10146,7 +10144,7 @@
                           <a:ea typeface="Calibri" pitchFamily="34" charset="-122"/>
                           <a:cs typeface="Calibri" pitchFamily="34" charset="-120"/>
                         </a:rPr>
-                        <a:t>jamais écrasé (Mongo = référence)</a:t>
+                        <a:t>jamais écrasé, même après retour vers MySQL</a:t>
                       </a:r>
                       <a:endParaRPr lang="en-US" sz="1300" dirty="0">
                         <a:latin typeface="Calibri" charset="0"/>
@@ -10232,7 +10230,7 @@
                 <a:ea typeface="Calibri" pitchFamily="34" charset="-122"/>
                 <a:cs typeface="Calibri" pitchFamily="34" charset="-120"/>
               </a:rPr>
-              <a:t>Relancer le DAG : 0 insertion, 0 mise à jour, 201 inchangés.</a:t>
+              <a:t>Sur une base fraîche : relancer l’import ne crée aucun doublon.</a:t>
             </a:r>
             <a:endParaRPr lang="en-US" sz="1300" dirty="0"/>
           </a:p>
@@ -11651,7 +11649,7 @@
               <a:buNone/>
             </a:pPr>
             <a:r>
-              <a:rPr lang="en-US" sz="1400" dirty="0">
+              <a:rPr lang="en-US" sz="1400" b="1" dirty="0">
                 <a:solidFill>
                   <a:schemeClr val="tx2"/>
                 </a:solidFill>
@@ -11659,9 +11657,8 @@
                 <a:ea typeface="Calibri" pitchFamily="34" charset="-122"/>
                 <a:cs typeface="Calibri" pitchFamily="34" charset="-120"/>
               </a:rPr>
-              <a:t>http://localhost:8080/soap/clients?wsdl   —   testé sur la pile Docker (18 cas) · requêtes SoapUI fournies</a:t>
-            </a:r>
-            <a:endParaRPr lang="en-US" sz="1400" dirty="0"/>
+              <a:t>23 tests SOAP sur pile Docker réelle · requêtes SoapUI fournies</a:t>
+            </a:r>
           </a:p>
         </p:txBody>
       </p:sp>
@@ -13225,7 +13222,7 @@
                 <a:ea typeface="Calibri" pitchFamily="34" charset="-122"/>
                 <a:cs typeface="Calibri" pitchFamily="34" charset="-120"/>
               </a:rPr>
-              <a:t>Statut HTTP 500 pour tout Fault (SOAP 1.1) · détail typé par le WSDL · les erreurs techniques ne divulguent aucun détail interne.</a:t>
+              <a:t>Fault : HTTP 500. Détail métier typé par le WSDL ; une erreur d’enveloppe peut ne pas avoir de détail métier.</a:t>
             </a:r>
             <a:endParaRPr lang="en-US" sz="1300" dirty="0"/>
           </a:p>
@@ -13688,7 +13685,7 @@
                 <a:ea typeface="Calibri" pitchFamily="34" charset="-122"/>
                 <a:cs typeface="Calibri" pitchFamily="34" charset="-120"/>
               </a:rPr>
-              <a:t>ignore ce client</a:t>
+              <a:t>ignore les fiches SOAP</a:t>
             </a:r>
             <a:endParaRPr lang="en-US" sz="1200" dirty="0"/>
           </a:p>
@@ -13705,9 +13702,8 @@
                 <a:ea typeface="Calibri" pitchFamily="34" charset="-122"/>
                 <a:cs typeface="Calibri" pitchFamily="34" charset="-120"/>
               </a:rPr>
-              <a:t>(conflits évités)</a:t>
-            </a:r>
-            <a:endParaRPr lang="en-US" sz="1200" dirty="0"/>
+              <a:t>même après réconciliation</a:t>
+            </a:r>
           </a:p>
         </p:txBody>
       </p:sp>

</xml_diff>

<commit_message>
Je restaure la documentation, et suppression des scripts qui sonthors sujet, ainsi que les noms des membres
</commit_message>
<xml_diff>
--- a/presentation/PRESENTATION_SOAP_CLIENTS.pptx
+++ b/presentation/PRESENTATION_SOAP_CLIENTS.pptx
@@ -4292,6 +4292,10 @@
             <a:prstDash val="solid"/>
           </a:ln>
         </p:spPr>
+        <p:txBody>
+          <a:bodyPr/>
+          <a:p/>
+        </p:txBody>
       </p:sp>
       <p:sp>
         <p:nvSpPr>
@@ -4317,6 +4321,10 @@
             <a:prstDash val="solid"/>
           </a:ln>
         </p:spPr>
+        <p:txBody>
+          <a:bodyPr/>
+          <a:p/>
+        </p:txBody>
       </p:sp>
       <p:pic>
         <p:nvPicPr>
@@ -4375,7 +4383,7 @@
                 <a:ea typeface="Calibri" pitchFamily="34" charset="-122"/>
                 <a:cs typeface="Calibri" pitchFamily="34" charset="-120"/>
               </a:rPr>
-              <a:t>Membre 1</a:t>
+              <a:t>Gildas KOANDA</a:t>
             </a:r>
             <a:endParaRPr lang="en-US" sz="1400" dirty="0"/>
           </a:p>
@@ -4446,6 +4454,10 @@
             <a:prstDash val="solid"/>
           </a:ln>
         </p:spPr>
+        <p:txBody>
+          <a:bodyPr/>
+          <a:p/>
+        </p:txBody>
       </p:sp>
       <p:sp>
         <p:nvSpPr>
@@ -4471,6 +4483,10 @@
             <a:prstDash val="solid"/>
           </a:ln>
         </p:spPr>
+        <p:txBody>
+          <a:bodyPr/>
+          <a:p/>
+        </p:txBody>
       </p:sp>
       <p:pic>
         <p:nvPicPr>
@@ -4529,7 +4545,7 @@
                 <a:ea typeface="Calibri" pitchFamily="34" charset="-122"/>
                 <a:cs typeface="Calibri" pitchFamily="34" charset="-120"/>
               </a:rPr>
-              <a:t>Membre 2</a:t>
+              <a:t>Michail SANKARA</a:t>
             </a:r>
             <a:endParaRPr lang="en-US" sz="1400" dirty="0"/>
           </a:p>
@@ -4600,6 +4616,10 @@
             <a:prstDash val="solid"/>
           </a:ln>
         </p:spPr>
+        <p:txBody>
+          <a:bodyPr/>
+          <a:p/>
+        </p:txBody>
       </p:sp>
       <p:sp>
         <p:nvSpPr>
@@ -4625,6 +4645,10 @@
             <a:prstDash val="solid"/>
           </a:ln>
         </p:spPr>
+        <p:txBody>
+          <a:bodyPr/>
+          <a:p/>
+        </p:txBody>
       </p:sp>
       <p:pic>
         <p:nvPicPr>
@@ -4683,7 +4707,7 @@
                 <a:ea typeface="Calibri" pitchFamily="34" charset="-122"/>
                 <a:cs typeface="Calibri" pitchFamily="34" charset="-120"/>
               </a:rPr>
-              <a:t>Membre 3</a:t>
+              <a:t>El Nour BARRY</a:t>
             </a:r>
             <a:endParaRPr lang="en-US" sz="1400" dirty="0"/>
           </a:p>
@@ -4754,6 +4778,10 @@
             <a:prstDash val="solid"/>
           </a:ln>
         </p:spPr>
+        <p:txBody>
+          <a:bodyPr/>
+          <a:p/>
+        </p:txBody>
       </p:sp>
       <p:sp>
         <p:nvSpPr>
@@ -4779,6 +4807,10 @@
             <a:prstDash val="solid"/>
           </a:ln>
         </p:spPr>
+        <p:txBody>
+          <a:bodyPr/>
+          <a:p/>
+        </p:txBody>
       </p:sp>
       <p:pic>
         <p:nvPicPr>
@@ -4837,7 +4869,7 @@
                 <a:ea typeface="Calibri" pitchFamily="34" charset="-122"/>
                 <a:cs typeface="Calibri" pitchFamily="34" charset="-120"/>
               </a:rPr>
-              <a:t>Membre 4</a:t>
+              <a:t>Cephas CONGO</a:t>
             </a:r>
             <a:endParaRPr lang="en-US" sz="1400" dirty="0"/>
           </a:p>
@@ -4908,6 +4940,10 @@
             <a:prstDash val="solid"/>
           </a:ln>
         </p:spPr>
+        <p:txBody>
+          <a:bodyPr/>
+          <a:p/>
+        </p:txBody>
       </p:sp>
       <p:sp>
         <p:nvSpPr>
@@ -4933,6 +4969,10 @@
             <a:prstDash val="solid"/>
           </a:ln>
         </p:spPr>
+        <p:txBody>
+          <a:bodyPr/>
+          <a:p/>
+        </p:txBody>
       </p:sp>
       <p:pic>
         <p:nvPicPr>
@@ -4991,7 +5031,7 @@
                 <a:ea typeface="Calibri" pitchFamily="34" charset="-122"/>
                 <a:cs typeface="Calibri" pitchFamily="34" charset="-120"/>
               </a:rPr>
-              <a:t>Membre 5</a:t>
+              <a:t>Assita KONE</a:t>
             </a:r>
             <a:endParaRPr lang="en-US" sz="1400" dirty="0"/>
           </a:p>
@@ -5069,7 +5109,7 @@
                 <a:ea typeface="Calibri" pitchFamily="34" charset="-122"/>
                 <a:cs typeface="Calibri" pitchFamily="34" charset="-120"/>
               </a:rPr>
-              <a:t>Noms et rôles à ajuster par le groupe.</a:t>
+              <a:t>Groupe 5 — Sécurité informatique (SI)</a:t>
             </a:r>
             <a:endParaRPr lang="en-US" sz="1100" dirty="0"/>
           </a:p>

</xml_diff>